<commit_message>
Slides: badged PPTX of sd-04-040
</commit_message>
<xml_diff>
--- a/system-design-101/vi/lessons/sd-04-040/slides/sd-04-040.pptx
+++ b/system-design-101/vi/lessons/sd-04-040/slides/sd-04-040.pptx
@@ -10595,10 +10595,10 @@
                 <a:ea typeface="Be Vietnam Pro" pitchFamily="34" charset="-122"/>
                 <a:cs typeface="Be Vietnam Pro" pitchFamily="34" charset="-120"/>
               </a:rPr>
-              <a:t> ĐO</a:t>
-            </a:r>
-            <a:r>
-              <a:rPr lang="en-US" sz="1950" b="1" spc="222" kern="0" dirty="0">
+              <a:t> ĐO 1</a:t>
+            </a:r>
+            <a:r>
+              <a:rPr lang="en-US" sz="1950" b="1" spc="225" kern="0" dirty="0">
                 <a:solidFill>
                   <a:srgbClr val="FF6A4D"/>
                 </a:solidFill>
@@ -10606,7 +10606,7 @@
                 <a:ea typeface="Be Vietnam Pro" pitchFamily="34" charset="-122"/>
                 <a:cs typeface="Be Vietnam Pro" pitchFamily="34" charset="-120"/>
               </a:rPr>
-              <a:t> ·</a:t>
+              <a:t> TRIỆU</a:t>
             </a:r>
             <a:r>
               <a:rPr lang="en-US" sz="1950" b="1" spc="226" kern="0" dirty="0">
@@ -10617,43 +10617,21 @@
                 <a:ea typeface="Be Vietnam Pro" pitchFamily="34" charset="-122"/>
                 <a:cs typeface="Be Vietnam Pro" pitchFamily="34" charset="-120"/>
               </a:rPr>
-              <a:t> 1</a:t>
+              <a:t> DÒNG</a:t>
+            </a:r>
+            <a:r>
+              <a:rPr lang="en-US" sz="1950" b="1" spc="219" kern="0" dirty="0">
+                <a:solidFill>
+                  <a:srgbClr val="FF6A4D"/>
+                </a:solidFill>
+                <a:latin typeface="Be Vietnam Pro" pitchFamily="34" charset="0"/>
+                <a:ea typeface="Be Vietnam Pro" pitchFamily="34" charset="-122"/>
+                <a:cs typeface="Be Vietnam Pro" pitchFamily="34" charset="-120"/>
+              </a:rPr>
+              <a:t> BÁN</a:t>
             </a:r>
             <a:r>
               <a:rPr lang="en-US" sz="1950" b="1" spc="225" kern="0" dirty="0">
-                <a:solidFill>
-                  <a:srgbClr val="FF6A4D"/>
-                </a:solidFill>
-                <a:latin typeface="Be Vietnam Pro" pitchFamily="34" charset="0"/>
-                <a:ea typeface="Be Vietnam Pro" pitchFamily="34" charset="-122"/>
-                <a:cs typeface="Be Vietnam Pro" pitchFamily="34" charset="-120"/>
-              </a:rPr>
-              <a:t> TRIỆU</a:t>
-            </a:r>
-            <a:r>
-              <a:rPr lang="en-US" sz="1950" b="1" spc="226" kern="0" dirty="0">
-                <a:solidFill>
-                  <a:srgbClr val="FF6A4D"/>
-                </a:solidFill>
-                <a:latin typeface="Be Vietnam Pro" pitchFamily="34" charset="0"/>
-                <a:ea typeface="Be Vietnam Pro" pitchFamily="34" charset="-122"/>
-                <a:cs typeface="Be Vietnam Pro" pitchFamily="34" charset="-120"/>
-              </a:rPr>
-              <a:t> DÒNG</a:t>
-            </a:r>
-            <a:r>
-              <a:rPr lang="en-US" sz="1950" b="1" spc="218" kern="0" dirty="0">
-                <a:solidFill>
-                  <a:srgbClr val="FF6A4D"/>
-                </a:solidFill>
-                <a:latin typeface="Be Vietnam Pro" pitchFamily="34" charset="0"/>
-                <a:ea typeface="Be Vietnam Pro" pitchFamily="34" charset="-122"/>
-                <a:cs typeface="Be Vietnam Pro" pitchFamily="34" charset="-120"/>
-              </a:rPr>
-              <a:t> BÁN</a:t>
-            </a:r>
-            <a:r>
-              <a:rPr lang="en-US" sz="1950" b="1" spc="226" kern="0" dirty="0">
                 <a:solidFill>
                   <a:srgbClr val="FF6A4D"/>
                 </a:solidFill>

</xml_diff>